<commit_message>
Slides: sd-13-006 slide 3 compares targetPort with the container port
Co-Authored-By: Claude Opus 5.5 <noreply@anthropic.com>
Claude-Session: https://claude.ai/code/session_01TQmrJYLm4GPgtXpQaEk7ey
</commit_message>
<xml_diff>
--- a/system-design-101/vi/lessons/sd-13-006/slides/sd-13-006.pptx
+++ b/system-design-101/vi/lessons/sd-13-006/slides/sd-13-006.pptx
@@ -6826,12 +6826,15 @@
               <a:lnSpc>
                 <a:spcPts val="3570"/>
               </a:lnSpc>
+              <a:spcAft>
+                <a:spcPts val="600"/>
+              </a:spcAft>
               <a:buSzPct val="100000"/>
               <a:buFont typeface="Arial"/>
               <a:buChar char="•"/>
             </a:pPr>
             <a:r>
-              <a:rPr lang="en-US" sz="2550" dirty="0" spc="-3" kern="0">
+              <a:rPr lang="en-US" sz="2550" dirty="0" spc="-26" kern="0">
                 <a:solidFill>
                   <a:srgbClr val="E4E1D8"/>
                 </a:solidFill>
@@ -6839,7 +6842,106 @@
                 <a:ea typeface="Be Vietnam Pro" pitchFamily="34" charset="-122"/>
                 <a:cs typeface="Be Vietnam Pro" pitchFamily="34" charset="-120"/>
               </a:rPr>
-              <a:t>So</a:t>
+              <a:t>targetPort</a:t>
+            </a:r>
+            <a:r>
+              <a:rPr lang="en-US" sz="2550" dirty="0" spc="0" kern="0">
+                <a:solidFill>
+                  <a:srgbClr val="E4E1D8"/>
+                </a:solidFill>
+                <a:latin typeface="Be Vietnam Pro" pitchFamily="34" charset="0"/>
+                <a:ea typeface="Be Vietnam Pro" pitchFamily="34" charset="-122"/>
+                <a:cs typeface="Be Vietnam Pro" pitchFamily="34" charset="-120"/>
+              </a:rPr>
+              <a:t> phải khớp cổng</a:t>
+            </a:r>
+            <a:r>
+              <a:rPr lang="en-US" sz="2550" dirty="0" spc="-10" kern="0">
+                <a:solidFill>
+                  <a:srgbClr val="E4E1D8"/>
+                </a:solidFill>
+                <a:latin typeface="Be Vietnam Pro" pitchFamily="34" charset="0"/>
+                <a:ea typeface="Be Vietnam Pro" pitchFamily="34" charset="-122"/>
+                <a:cs typeface="Be Vietnam Pro" pitchFamily="34" charset="-120"/>
+              </a:rPr>
+              <a:t> container</a:t>
+            </a:r>
+            <a:r>
+              <a:rPr lang="en-US" sz="2550" dirty="0" spc="-1" kern="0">
+                <a:solidFill>
+                  <a:srgbClr val="E4E1D8"/>
+                </a:solidFill>
+                <a:latin typeface="Be Vietnam Pro" pitchFamily="34" charset="0"/>
+                <a:ea typeface="Be Vietnam Pro" pitchFamily="34" charset="-122"/>
+                <a:cs typeface="Be Vietnam Pro" pitchFamily="34" charset="-120"/>
+              </a:rPr>
+              <a:t> nhận</a:t>
+            </a:r>
+            <a:r>
+              <a:rPr lang="en-US" sz="2550" dirty="0" spc="-18" kern="0">
+                <a:solidFill>
+                  <a:srgbClr val="E4E1D8"/>
+                </a:solidFill>
+                <a:latin typeface="Be Vietnam Pro" pitchFamily="34" charset="0"/>
+                <a:ea typeface="Be Vietnam Pro" pitchFamily="34" charset="-122"/>
+                <a:cs typeface="Be Vietnam Pro" pitchFamily="34" charset="-120"/>
+              </a:rPr>
+              <a:t> traffic.</a:t>
+            </a:r>
+            <a:endParaRPr lang="en-US" sz="2550" dirty="0"/>
+          </a:p>
+          <a:p>
+            <a:pPr algn="l" marL="323850" indent="-231371">
+              <a:lnSpc>
+                <a:spcPts val="3570"/>
+              </a:lnSpc>
+              <a:buSzPct val="100000"/>
+              <a:buFont typeface="Arial"/>
+              <a:buChar char="•"/>
+            </a:pPr>
+            <a:r>
+              <a:rPr lang="en-US" sz="2550" dirty="0" spc="-1" kern="0">
+                <a:solidFill>
+                  <a:srgbClr val="E4E1D8"/>
+                </a:solidFill>
+                <a:latin typeface="Be Vietnam Pro" pitchFamily="34" charset="0"/>
+                <a:ea typeface="Be Vietnam Pro" pitchFamily="34" charset="-122"/>
+                <a:cs typeface="Be Vietnam Pro" pitchFamily="34" charset="-120"/>
+              </a:rPr>
+              <a:t>Không ghi</a:t>
+            </a:r>
+            <a:r>
+              <a:rPr lang="en-US" sz="2550" dirty="0" spc="-24" kern="0">
+                <a:solidFill>
+                  <a:srgbClr val="E4E1D8"/>
+                </a:solidFill>
+                <a:latin typeface="Be Vietnam Pro" pitchFamily="34" charset="0"/>
+                <a:ea typeface="Be Vietnam Pro" pitchFamily="34" charset="-122"/>
+                <a:cs typeface="Be Vietnam Pro" pitchFamily="34" charset="-120"/>
+              </a:rPr>
+              <a:t> targetPort</a:t>
+            </a:r>
+            <a:r>
+              <a:rPr lang="en-US" sz="2550" dirty="0" spc="2" kern="0">
+                <a:solidFill>
+                  <a:srgbClr val="E4E1D8"/>
+                </a:solidFill>
+                <a:latin typeface="Be Vietnam Pro" pitchFamily="34" charset="0"/>
+                <a:ea typeface="Be Vietnam Pro" pitchFamily="34" charset="-122"/>
+                <a:cs typeface="Be Vietnam Pro" pitchFamily="34" charset="-120"/>
+              </a:rPr>
+              <a:t> thì</a:t>
+            </a:r>
+            <a:r>
+              <a:rPr lang="en-US" sz="2550" dirty="0" spc="0" kern="0">
+                <a:solidFill>
+                  <a:srgbClr val="E4E1D8"/>
+                </a:solidFill>
+                <a:latin typeface="Be Vietnam Pro" pitchFamily="34" charset="0"/>
+                <a:ea typeface="Be Vietnam Pro" pitchFamily="34" charset="-122"/>
+                <a:cs typeface="Be Vietnam Pro" pitchFamily="34" charset="-120"/>
+              </a:rPr>
+              <a:t> nó</a:t>
             </a:r>
             <a:r>
               <a:rPr lang="en-US" sz="2550" dirty="0" spc="-2" kern="0">
@@ -6850,7 +6952,7 @@
                 <a:ea typeface="Be Vietnam Pro" pitchFamily="34" charset="-122"/>
                 <a:cs typeface="Be Vietnam Pro" pitchFamily="34" charset="-120"/>
               </a:rPr>
-              <a:t> port của</a:t>
+              <a:t> bằng</a:t>
             </a:r>
             <a:r>
               <a:rPr lang="en-US" sz="2550" dirty="0" spc="-1" kern="0">
@@ -6861,51 +6963,7 @@
                 <a:ea typeface="Be Vietnam Pro" pitchFamily="34" charset="-122"/>
                 <a:cs typeface="Be Vietnam Pro" pitchFamily="34" charset="-120"/>
               </a:rPr>
-              <a:t> Service</a:t>
-            </a:r>
-            <a:r>
-              <a:rPr lang="en-US" sz="2550" dirty="0" spc="-15" kern="0">
-                <a:solidFill>
-                  <a:srgbClr val="E4E1D8"/>
-                </a:solidFill>
-                <a:latin typeface="Be Vietnam Pro" pitchFamily="34" charset="0"/>
-                <a:ea typeface="Be Vietnam Pro" pitchFamily="34" charset="-122"/>
-                <a:cs typeface="Be Vietnam Pro" pitchFamily="34" charset="-120"/>
-              </a:rPr>
-              <a:t> với</a:t>
-            </a:r>
-            <a:r>
-              <a:rPr lang="en-US" sz="2550" dirty="0" spc="-24" kern="0">
-                <a:solidFill>
-                  <a:srgbClr val="E4E1D8"/>
-                </a:solidFill>
-                <a:latin typeface="Be Vietnam Pro" pitchFamily="34" charset="0"/>
-                <a:ea typeface="Be Vietnam Pro" pitchFamily="34" charset="-122"/>
-                <a:cs typeface="Be Vietnam Pro" pitchFamily="34" charset="-120"/>
-              </a:rPr>
-              <a:t> targetPort</a:t>
-            </a:r>
-            <a:r>
-              <a:rPr lang="en-US" sz="2550" dirty="0" spc="-1" kern="0">
-                <a:solidFill>
-                  <a:srgbClr val="E4E1D8"/>
-                </a:solidFill>
-                <a:latin typeface="Be Vietnam Pro" pitchFamily="34" charset="0"/>
-                <a:ea typeface="Be Vietnam Pro" pitchFamily="34" charset="-122"/>
-                <a:cs typeface="Be Vietnam Pro" pitchFamily="34" charset="-120"/>
-              </a:rPr>
-              <a:t> của</a:t>
-            </a:r>
-            <a:r>
-              <a:rPr lang="en-US" sz="2550" dirty="0" spc="-11" kern="0">
-                <a:solidFill>
-                  <a:srgbClr val="E4E1D8"/>
-                </a:solidFill>
-                <a:latin typeface="Be Vietnam Pro" pitchFamily="34" charset="0"/>
-                <a:ea typeface="Be Vietnam Pro" pitchFamily="34" charset="-122"/>
-                <a:cs typeface="Be Vietnam Pro" pitchFamily="34" charset="-120"/>
-              </a:rPr>
-              <a:t> Pod.</a:t>
+              <a:t> port.</a:t>
             </a:r>
             <a:endParaRPr lang="en-US" sz="2550" dirty="0"/>
           </a:p>

</xml_diff>

<commit_message>
Slides: sd-13 content tables at 34 px
Co-Authored-By: Claude Opus 5.5 <noreply@anthropic.com>
Claude-Session: https://claude.ai/code/session_01TQmrJYLm4GPgtXpQaEk7ey
</commit_message>
<xml_diff>
--- a/system-design-101/vi/lessons/sd-13-006/slides/sd-13-006.pptx
+++ b/system-design-101/vi/lessons/sd-13-006/slides/sd-13-006.pptx
@@ -14365,12 +14365,12 @@
                     <a:p>
                       <a:pPr algn="l" indent="0" marL="0">
                         <a:lnSpc>
-                          <a:spcPts val="2880"/>
+                          <a:spcPts val="3060"/>
                         </a:lnSpc>
                         <a:buNone/>
                       </a:pPr>
                       <a:r>
-                        <a:rPr lang="en-US" sz="2400" b="1" dirty="0" spc="-5" kern="0">
+                        <a:rPr lang="en-US" sz="2550" b="1" dirty="0" spc="-4" kern="0">
                           <a:solidFill>
                             <a:srgbClr val="F3EEE3"/>
                           </a:solidFill>
@@ -14381,7 +14381,7 @@
                         <a:t>Chỗ</a:t>
                       </a:r>
                       <a:r>
-                        <a:rPr lang="en-US" sz="2400" b="1" dirty="0" spc="-4" kern="0">
+                        <a:rPr lang="en-US" sz="2550" b="1" dirty="0" spc="-2" kern="0">
                           <a:solidFill>
                             <a:srgbClr val="F3EEE3"/>
                           </a:solidFill>
@@ -14392,7 +14392,7 @@
                         <a:t> kiểm</a:t>
                       </a:r>
                       <a:r>
-                        <a:rPr lang="en-US" sz="2400" b="1" dirty="0" spc="-10" kern="0">
+                        <a:rPr lang="en-US" sz="2550" b="1" dirty="0" spc="-14" kern="0">
                           <a:solidFill>
                             <a:srgbClr val="F3EEE3"/>
                           </a:solidFill>
@@ -14405,7 +14405,7 @@
                       <a:endParaRPr lang="en-US" sz="1200" dirty="0"/>
                     </a:p>
                   </a:txBody>
-                  <a:tcPr marL="304800" marR="304800" marT="304800" marB="304800" anchor="ctr">
+                  <a:tcPr marL="304800" marR="304800" marT="300990" marB="300990" anchor="ctr">
                     <a:lnL w="0" cap="flat" cmpd="sng" algn="ctr">
                       <a:noFill/>
                     </a:lnL>
@@ -14430,12 +14430,12 @@
                     <a:p>
                       <a:pPr algn="l" indent="0" marL="0">
                         <a:lnSpc>
-                          <a:spcPts val="2880"/>
+                          <a:spcPts val="3060"/>
                         </a:lnSpc>
                         <a:buNone/>
                       </a:pPr>
                       <a:r>
-                        <a:rPr lang="en-US" sz="2400" b="1" dirty="0" spc="2" kern="0">
+                        <a:rPr lang="en-US" sz="2550" b="1" dirty="0" spc="4" kern="0">
                           <a:solidFill>
                             <a:srgbClr val="F3EEE3"/>
                           </a:solidFill>
@@ -14446,7 +14446,7 @@
                         <a:t>Cần</a:t>
                       </a:r>
                       <a:r>
-                        <a:rPr lang="en-US" sz="2400" b="1" dirty="0" spc="-4" kern="0">
+                        <a:rPr lang="en-US" sz="2550" b="1" dirty="0" spc="-3" kern="0">
                           <a:solidFill>
                             <a:srgbClr val="F3EEE3"/>
                           </a:solidFill>
@@ -14459,7 +14459,7 @@
                       <a:endParaRPr lang="en-US" sz="1200" dirty="0"/>
                     </a:p>
                   </a:txBody>
-                  <a:tcPr marL="304800" marR="304800" marT="304800" marB="304800" anchor="ctr">
+                  <a:tcPr marL="304800" marR="304800" marT="300990" marB="300990" anchor="ctr">
                     <a:lnL w="19050" cap="flat" cmpd="sng" algn="ctr">
                       <a:solidFill>
                         <a:srgbClr val="3A3F4D"/>
@@ -14492,12 +14492,12 @@
                     <a:p>
                       <a:pPr algn="l" indent="0" marL="0">
                         <a:lnSpc>
-                          <a:spcPts val="2880"/>
+                          <a:spcPts val="3060"/>
                         </a:lnSpc>
                         <a:buNone/>
                       </a:pPr>
                       <a:r>
-                        <a:rPr lang="en-US" sz="2400" dirty="0" spc="-7" kern="0">
+                        <a:rPr lang="en-US" sz="2550" dirty="0" spc="-7" kern="0">
                           <a:solidFill>
                             <a:srgbClr val="F3EEE3"/>
                           </a:solidFill>
@@ -14510,7 +14510,7 @@
                       <a:endParaRPr lang="en-US" sz="1200" dirty="0"/>
                     </a:p>
                   </a:txBody>
-                  <a:tcPr marL="304800" marR="304800" marT="304800" marB="304800" anchor="ctr">
+                  <a:tcPr marL="304800" marR="304800" marT="300990" marB="300990" anchor="ctr">
                     <a:lnL w="0" cap="flat" cmpd="sng" algn="ctr">
                       <a:noFill/>
                     </a:lnL>
@@ -14541,12 +14541,12 @@
                     <a:p>
                       <a:pPr algn="l" indent="0" marL="0">
                         <a:lnSpc>
-                          <a:spcPts val="2880"/>
+                          <a:spcPts val="3060"/>
                         </a:lnSpc>
                         <a:buNone/>
                       </a:pPr>
                       <a:r>
-                        <a:rPr lang="en-US" sz="2400" dirty="0" spc="-1" kern="0">
+                        <a:rPr lang="en-US" sz="2550" dirty="0" spc="1" kern="0">
                           <a:solidFill>
                             <a:srgbClr val="F3EEE3"/>
                           </a:solidFill>
@@ -14557,7 +14557,7 @@
                         <a:t>Mặc</a:t>
                       </a:r>
                       <a:r>
-                        <a:rPr lang="en-US" sz="2400" dirty="0" spc="20" kern="0">
+                        <a:rPr lang="en-US" sz="2550" dirty="0" spc="21" kern="0">
                           <a:solidFill>
                             <a:srgbClr val="F3EEE3"/>
                           </a:solidFill>
@@ -14568,7 +14568,7 @@
                         <a:t> định</a:t>
                       </a:r>
                       <a:r>
-                        <a:rPr lang="en-US" sz="2400" dirty="0" spc="-1" kern="0">
+                        <a:rPr lang="en-US" sz="2550" dirty="0" spc="0" kern="0">
                           <a:solidFill>
                             <a:srgbClr val="F3EEE3"/>
                           </a:solidFill>
@@ -14579,7 +14579,7 @@
                         <a:t> chỉ</a:t>
                       </a:r>
                       <a:r>
-                        <a:rPr lang="en-US" sz="2400" dirty="0" spc="-6" kern="0">
+                        <a:rPr lang="en-US" sz="2550" dirty="0" spc="-7" kern="0">
                           <a:solidFill>
                             <a:srgbClr val="F3EEE3"/>
                           </a:solidFill>
@@ -14590,7 +14590,7 @@
                         <a:t> endpoint</a:t>
                       </a:r>
                       <a:r>
-                        <a:rPr lang="en-US" sz="2400" dirty="0" spc="-16" kern="0">
+                        <a:rPr lang="en-US" sz="2550" dirty="0" spc="-19" kern="0">
                           <a:solidFill>
                             <a:srgbClr val="F3EEE3"/>
                           </a:solidFill>
@@ -14601,7 +14601,7 @@
                         <a:t> ready</a:t>
                       </a:r>
                       <a:r>
-                        <a:rPr lang="en-US" sz="2400" dirty="0" spc="2" kern="0">
+                        <a:rPr lang="en-US" sz="2550" dirty="0" spc="0" kern="0">
                           <a:solidFill>
                             <a:srgbClr val="F3EEE3"/>
                           </a:solidFill>
@@ -14612,7 +14612,7 @@
                         <a:t> nhận</a:t>
                       </a:r>
                       <a:r>
-                        <a:rPr lang="en-US" sz="2400" dirty="0" spc="-19" kern="0">
+                        <a:rPr lang="en-US" sz="2550" dirty="0" spc="-21" kern="0">
                           <a:solidFill>
                             <a:srgbClr val="F3EEE3"/>
                           </a:solidFill>
@@ -14625,7 +14625,7 @@
                       <a:endParaRPr lang="en-US" sz="1200" dirty="0"/>
                     </a:p>
                   </a:txBody>
-                  <a:tcPr marL="304800" marR="304800" marT="304800" marB="304800" anchor="ctr">
+                  <a:tcPr marL="304800" marR="304800" marT="300990" marB="300990" anchor="ctr">
                     <a:lnL w="19050" cap="flat" cmpd="sng" algn="ctr">
                       <a:solidFill>
                         <a:srgbClr val="3A3F4D"/>
@@ -14664,12 +14664,12 @@
                     <a:p>
                       <a:pPr algn="l" indent="0" marL="0">
                         <a:lnSpc>
-                          <a:spcPts val="2880"/>
+                          <a:spcPts val="3060"/>
                         </a:lnSpc>
                         <a:buNone/>
                       </a:pPr>
                       <a:r>
-                        <a:rPr lang="en-US" sz="2400" dirty="0" spc="-24" kern="0">
+                        <a:rPr lang="en-US" sz="2550" dirty="0" spc="-26" kern="0">
                           <a:solidFill>
                             <a:srgbClr val="F3EEE3"/>
                           </a:solidFill>
@@ -14682,7 +14682,7 @@
                       <a:endParaRPr lang="en-US" sz="1200" dirty="0"/>
                     </a:p>
                   </a:txBody>
-                  <a:tcPr marL="304800" marR="304800" marT="304800" marB="304800" anchor="ctr">
+                  <a:tcPr marL="304800" marR="304800" marT="300990" marB="300990" anchor="ctr">
                     <a:lnL w="0" cap="flat" cmpd="sng" algn="ctr">
                       <a:noFill/>
                     </a:lnL>
@@ -14713,12 +14713,12 @@
                     <a:p>
                       <a:pPr algn="l" indent="0" marL="0">
                         <a:lnSpc>
-                          <a:spcPts val="2880"/>
+                          <a:spcPts val="3060"/>
                         </a:lnSpc>
                         <a:buNone/>
                       </a:pPr>
                       <a:r>
-                        <a:rPr lang="en-US" sz="2400" dirty="0" spc="2" kern="0">
+                        <a:rPr lang="en-US" sz="2550" dirty="0" spc="-1" kern="0">
                           <a:solidFill>
                             <a:srgbClr val="F3EEE3"/>
                           </a:solidFill>
@@ -14726,10 +14726,10 @@
                           <a:ea typeface="Be Vietnam Pro" pitchFamily="34" charset="-122"/>
                           <a:cs typeface="Be Vietnam Pro" pitchFamily="34" charset="-120"/>
                         </a:rPr>
-                        <a:t>Không</a:t>
+                        <a:t>Không ghi</a:t>
                       </a:r>
                       <a:r>
-                        <a:rPr lang="en-US" sz="2400" dirty="0" spc="1" kern="0">
+                        <a:rPr lang="en-US" sz="2550" dirty="0" spc="2" kern="0">
                           <a:solidFill>
                             <a:srgbClr val="F3EEE3"/>
                           </a:solidFill>
@@ -14737,10 +14737,10 @@
                           <a:ea typeface="Be Vietnam Pro" pitchFamily="34" charset="-122"/>
                           <a:cs typeface="Be Vietnam Pro" pitchFamily="34" charset="-120"/>
                         </a:rPr>
-                        <a:t> ghi thì bằng</a:t>
+                        <a:t> thì</a:t>
                       </a:r>
                       <a:r>
-                        <a:rPr lang="en-US" sz="2400" dirty="0" spc="0" kern="0">
+                        <a:rPr lang="en-US" sz="2550" dirty="0" spc="-2" kern="0">
                           <a:solidFill>
                             <a:srgbClr val="F3EEE3"/>
                           </a:solidFill>
@@ -14748,21 +14748,10 @@
                           <a:ea typeface="Be Vietnam Pro" pitchFamily="34" charset="-122"/>
                           <a:cs typeface="Be Vietnam Pro" pitchFamily="34" charset="-120"/>
                         </a:rPr>
-                        <a:t> port</a:t>
+                        <a:t> bằng port của</a:t>
                       </a:r>
                       <a:r>
-                        <a:rPr lang="en-US" sz="2400" dirty="0" spc="2" kern="0">
-                          <a:solidFill>
-                            <a:srgbClr val="F3EEE3"/>
-                          </a:solidFill>
-                          <a:latin typeface="Be Vietnam Pro" pitchFamily="34" charset="0"/>
-                          <a:ea typeface="Be Vietnam Pro" pitchFamily="34" charset="-122"/>
-                          <a:cs typeface="Be Vietnam Pro" pitchFamily="34" charset="-120"/>
-                        </a:rPr>
-                        <a:t> của</a:t>
-                      </a:r>
-                      <a:r>
-                        <a:rPr lang="en-US" sz="2400" dirty="0" spc="-1" kern="0">
+                        <a:rPr lang="en-US" sz="2550" dirty="0" spc="-1" kern="0">
                           <a:solidFill>
                             <a:srgbClr val="F3EEE3"/>
                           </a:solidFill>
@@ -14775,7 +14764,7 @@
                       <a:endParaRPr lang="en-US" sz="1200" dirty="0"/>
                     </a:p>
                   </a:txBody>
-                  <a:tcPr marL="304800" marR="304800" marT="304800" marB="304800" anchor="ctr">
+                  <a:tcPr marL="304800" marR="304800" marT="300990" marB="300990" anchor="ctr">
                     <a:lnL w="19050" cap="flat" cmpd="sng" algn="ctr">
                       <a:solidFill>
                         <a:srgbClr val="3A3F4D"/>
@@ -14814,12 +14803,12 @@
                     <a:p>
                       <a:pPr algn="l" indent="0" marL="0">
                         <a:lnSpc>
-                          <a:spcPts val="2880"/>
+                          <a:spcPts val="3060"/>
                         </a:lnSpc>
                         <a:buNone/>
                       </a:pPr>
                       <a:r>
-                        <a:rPr lang="en-US" sz="2400" dirty="0" spc="-73" kern="0">
+                        <a:rPr lang="en-US" sz="2550" dirty="0" spc="-78" kern="0">
                           <a:solidFill>
                             <a:srgbClr val="F3EEE3"/>
                           </a:solidFill>
@@ -14830,7 +14819,7 @@
                         <a:t>Tên</a:t>
                       </a:r>
                       <a:r>
-                        <a:rPr lang="en-US" sz="2400" dirty="0" spc="-2" kern="0">
+                        <a:rPr lang="en-US" sz="2550" dirty="0" spc="-2" kern="0">
                           <a:solidFill>
                             <a:srgbClr val="F3EEE3"/>
                           </a:solidFill>
@@ -14843,7 +14832,7 @@
                       <a:endParaRPr lang="en-US" sz="1200" dirty="0"/>
                     </a:p>
                   </a:txBody>
-                  <a:tcPr marL="304800" marR="304800" marT="304800" marB="304800" anchor="ctr">
+                  <a:tcPr marL="304800" marR="304800" marT="300990" marB="300990" anchor="ctr">
                     <a:lnL w="0" cap="flat" cmpd="sng" algn="ctr">
                       <a:noFill/>
                     </a:lnL>
@@ -14874,12 +14863,12 @@
                     <a:p>
                       <a:pPr algn="l" indent="0" marL="0">
                         <a:lnSpc>
-                          <a:spcPts val="2880"/>
+                          <a:spcPts val="3060"/>
                         </a:lnSpc>
                         <a:buNone/>
                       </a:pPr>
                       <a:r>
-                        <a:rPr lang="en-US" sz="2400" dirty="0" spc="1" kern="0">
+                        <a:rPr lang="en-US" sz="2550" dirty="0" spc="-1" kern="0">
                           <a:solidFill>
                             <a:srgbClr val="F3EEE3"/>
                           </a:solidFill>
@@ -14887,21 +14876,10 @@
                           <a:ea typeface="Be Vietnam Pro" pitchFamily="34" charset="-122"/>
                           <a:cs typeface="Be Vietnam Pro" pitchFamily="34" charset="-120"/>
                         </a:rPr>
-                        <a:t>Khác</a:t>
+                        <a:t>Khác namespace:</a:t>
                       </a:r>
                       <a:r>
-                        <a:rPr lang="en-US" sz="2400" dirty="0" spc="0" kern="0">
-                          <a:solidFill>
-                            <a:srgbClr val="F3EEE3"/>
-                          </a:solidFill>
-                          <a:latin typeface="Be Vietnam Pro" pitchFamily="34" charset="0"/>
-                          <a:ea typeface="Be Vietnam Pro" pitchFamily="34" charset="-122"/>
-                          <a:cs typeface="Be Vietnam Pro" pitchFamily="34" charset="-120"/>
-                        </a:rPr>
-                        <a:t> namespace:</a:t>
-                      </a:r>
-                      <a:r>
-                        <a:rPr lang="en-US" sz="2400" dirty="0" spc="1" kern="0">
+                        <a:rPr lang="en-US" sz="2550" dirty="0" spc="2" kern="0">
                           <a:solidFill>
                             <a:srgbClr val="F3EEE3"/>
                           </a:solidFill>
@@ -14912,7 +14890,7 @@
                         <a:t> thêm</a:t>
                       </a:r>
                       <a:r>
-                        <a:rPr lang="en-US" sz="2400" dirty="0" spc="-12" kern="0">
+                        <a:rPr lang="en-US" sz="2550" dirty="0" spc="-12" kern="0">
                           <a:solidFill>
                             <a:srgbClr val="F3EEE3"/>
                           </a:solidFill>
@@ -14923,7 +14901,7 @@
                         <a:t> tên</a:t>
                       </a:r>
                       <a:r>
-                        <a:rPr lang="en-US" sz="2400" dirty="0" spc="0" kern="0">
+                        <a:rPr lang="en-US" sz="2550" dirty="0" spc="-1" kern="0">
                           <a:solidFill>
                             <a:srgbClr val="F3EEE3"/>
                           </a:solidFill>
@@ -14934,7 +14912,7 @@
                         <a:t> namespace</a:t>
                       </a:r>
                       <a:r>
-                        <a:rPr lang="en-US" sz="2400" dirty="0" spc="-11" kern="0">
+                        <a:rPr lang="en-US" sz="2550" dirty="0" spc="-14" kern="0">
                           <a:solidFill>
                             <a:srgbClr val="F3EEE3"/>
                           </a:solidFill>
@@ -14945,7 +14923,7 @@
                         <a:t> vào</a:t>
                       </a:r>
                       <a:r>
-                        <a:rPr lang="en-US" sz="2400" dirty="0" spc="-12" kern="0">
+                        <a:rPr lang="en-US" sz="2550" dirty="0" spc="-12" kern="0">
                           <a:solidFill>
                             <a:srgbClr val="F3EEE3"/>
                           </a:solidFill>
@@ -14958,7 +14936,7 @@
                       <a:endParaRPr lang="en-US" sz="1200" dirty="0"/>
                     </a:p>
                   </a:txBody>
-                  <a:tcPr marL="304800" marR="304800" marT="304800" marB="304800" anchor="ctr">
+                  <a:tcPr marL="304800" marR="304800" marT="300990" marB="300990" anchor="ctr">
                     <a:lnL w="19050" cap="flat" cmpd="sng" algn="ctr">
                       <a:solidFill>
                         <a:srgbClr val="3A3F4D"/>
@@ -14997,12 +14975,12 @@
                     <a:p>
                       <a:pPr algn="l" indent="0" marL="0">
                         <a:lnSpc>
-                          <a:spcPts val="2880"/>
+                          <a:spcPts val="3060"/>
                         </a:lnSpc>
                         <a:buNone/>
                       </a:pPr>
                       <a:r>
-                        <a:rPr lang="en-US" sz="2400" dirty="0" spc="-7" kern="0">
+                        <a:rPr lang="en-US" sz="2550" dirty="0" spc="-6" kern="0">
                           <a:solidFill>
                             <a:srgbClr val="F3EEE3"/>
                           </a:solidFill>
@@ -15015,7 +14993,7 @@
                       <a:endParaRPr lang="en-US" sz="1200" dirty="0"/>
                     </a:p>
                   </a:txBody>
-                  <a:tcPr marL="304800" marR="304800" marT="304800" marB="304800" anchor="ctr">
+                  <a:tcPr marL="304800" marR="304800" marT="300990" marB="300990" anchor="ctr">
                     <a:lnL w="0" cap="flat" cmpd="sng" algn="ctr">
                       <a:noFill/>
                     </a:lnL>
@@ -15046,12 +15024,12 @@
                     <a:p>
                       <a:pPr algn="l" indent="0" marL="0">
                         <a:lnSpc>
-                          <a:spcPts val="2880"/>
+                          <a:spcPts val="3060"/>
                         </a:lnSpc>
                         <a:buNone/>
                       </a:pPr>
                       <a:r>
-                        <a:rPr lang="en-US" sz="2400" dirty="0" spc="-1" kern="0">
+                        <a:rPr lang="en-US" sz="2550" dirty="0" spc="1" kern="0">
                           <a:solidFill>
                             <a:srgbClr val="F3EEE3"/>
                           </a:solidFill>
@@ -15062,7 +15040,7 @@
                         <a:t>Mặc</a:t>
                       </a:r>
                       <a:r>
-                        <a:rPr lang="en-US" sz="2400" dirty="0" spc="20" kern="0">
+                        <a:rPr lang="en-US" sz="2550" dirty="0" spc="21" kern="0">
                           <a:solidFill>
                             <a:srgbClr val="F3EEE3"/>
                           </a:solidFill>
@@ -15073,7 +15051,7 @@
                         <a:t> định</a:t>
                       </a:r>
                       <a:r>
-                        <a:rPr lang="en-US" sz="2400" dirty="0" spc="1" kern="0">
+                        <a:rPr lang="en-US" sz="2550" dirty="0" spc="0" kern="0">
                           <a:solidFill>
                             <a:srgbClr val="F3EEE3"/>
                           </a:solidFill>
@@ -15084,7 +15062,7 @@
                         <a:t> dải</a:t>
                       </a:r>
                       <a:r>
-                        <a:rPr lang="en-US" sz="2400" dirty="0" spc="-22" kern="0">
+                        <a:rPr lang="en-US" sz="2550" dirty="0" spc="-23" kern="0">
                           <a:solidFill>
                             <a:srgbClr val="F3EEE3"/>
                           </a:solidFill>
@@ -15095,7 +15073,7 @@
                         <a:t> 30000–32767</a:t>
                       </a:r>
                       <a:r>
-                        <a:rPr lang="en-US" sz="2400" dirty="0" spc="-17" kern="0">
+                        <a:rPr lang="en-US" sz="2550" dirty="0" spc="-19" kern="0">
                           <a:solidFill>
                             <a:srgbClr val="F3EEE3"/>
                           </a:solidFill>
@@ -15106,7 +15084,7 @@
                         <a:t> trên</a:t>
                       </a:r>
                       <a:r>
-                        <a:rPr lang="en-US" sz="2400" dirty="0" spc="2" kern="0">
+                        <a:rPr lang="en-US" sz="2550" dirty="0" spc="0" kern="0">
                           <a:solidFill>
                             <a:srgbClr val="F3EEE3"/>
                           </a:solidFill>
@@ -15117,7 +15095,7 @@
                         <a:t> mọi</a:t>
                       </a:r>
                       <a:r>
-                        <a:rPr lang="en-US" sz="2400" dirty="0" spc="-1" kern="0">
+                        <a:rPr lang="en-US" sz="2550" dirty="0" spc="-2" kern="0">
                           <a:solidFill>
                             <a:srgbClr val="F3EEE3"/>
                           </a:solidFill>
@@ -15130,7 +15108,7 @@
                       <a:endParaRPr lang="en-US" sz="1200" dirty="0"/>
                     </a:p>
                   </a:txBody>
-                  <a:tcPr marL="304800" marR="304800" marT="304800" marB="304800" anchor="ctr">
+                  <a:tcPr marL="304800" marR="304800" marT="300990" marB="300990" anchor="ctr">
                     <a:lnL w="19050" cap="flat" cmpd="sng" algn="ctr">
                       <a:solidFill>
                         <a:srgbClr val="3A3F4D"/>
@@ -15169,12 +15147,12 @@
                     <a:p>
                       <a:pPr algn="l" indent="0" marL="0">
                         <a:lnSpc>
-                          <a:spcPts val="2880"/>
+                          <a:spcPts val="3060"/>
                         </a:lnSpc>
                         <a:buNone/>
                       </a:pPr>
                       <a:r>
-                        <a:rPr lang="en-US" sz="2400" dirty="0" spc="-8" kern="0">
+                        <a:rPr lang="en-US" sz="2550" dirty="0" spc="-9" kern="0">
                           <a:solidFill>
                             <a:srgbClr val="F3EEE3"/>
                           </a:solidFill>
@@ -15187,7 +15165,7 @@
                       <a:endParaRPr lang="en-US" sz="1200" dirty="0"/>
                     </a:p>
                   </a:txBody>
-                  <a:tcPr marL="304800" marR="304800" marT="304800" marB="304800" anchor="ctr">
+                  <a:tcPr marL="304800" marR="304800" marT="300990" marB="300990" anchor="ctr">
                     <a:lnL w="0" cap="flat" cmpd="sng" algn="ctr">
                       <a:noFill/>
                     </a:lnL>
@@ -15218,12 +15196,12 @@
                     <a:p>
                       <a:pPr algn="l" indent="0" marL="0">
                         <a:lnSpc>
-                          <a:spcPts val="2880"/>
+                          <a:spcPts val="3060"/>
                         </a:lnSpc>
                         <a:buNone/>
                       </a:pPr>
                       <a:r>
-                        <a:rPr lang="en-US" sz="2400" dirty="0" spc="1" kern="0">
+                        <a:rPr lang="en-US" sz="2550" dirty="0" spc="1" kern="0">
                           <a:solidFill>
                             <a:srgbClr val="F3EEE3"/>
                           </a:solidFill>
@@ -15231,10 +15209,10 @@
                           <a:ea typeface="Be Vietnam Pro" pitchFamily="34" charset="-122"/>
                           <a:cs typeface="Be Vietnam Pro" pitchFamily="34" charset="-120"/>
                         </a:rPr>
-                        <a:t>Cần nhà</a:t>
+                        <a:t>Cần</a:t>
                       </a:r>
                       <a:r>
-                        <a:rPr lang="en-US" sz="2400" dirty="0" spc="0" kern="0">
+                        <a:rPr lang="en-US" sz="2550" dirty="0" spc="0" kern="0">
                           <a:solidFill>
                             <a:srgbClr val="F3EEE3"/>
                           </a:solidFill>
@@ -15242,10 +15220,10 @@
                           <a:ea typeface="Be Vietnam Pro" pitchFamily="34" charset="-122"/>
                           <a:cs typeface="Be Vietnam Pro" pitchFamily="34" charset="-120"/>
                         </a:rPr>
-                        <a:t> cung</a:t>
+                        <a:t> nhà</a:t>
                       </a:r>
                       <a:r>
-                        <a:rPr lang="en-US" sz="2400" dirty="0" spc="2" kern="0">
+                        <a:rPr lang="en-US" sz="2550" dirty="0" spc="1" kern="0">
                           <a:solidFill>
                             <a:srgbClr val="F3EEE3"/>
                           </a:solidFill>
@@ -15253,21 +15231,10 @@
                           <a:ea typeface="Be Vietnam Pro" pitchFamily="34" charset="-122"/>
                           <a:cs typeface="Be Vietnam Pro" pitchFamily="34" charset="-120"/>
                         </a:rPr>
-                        <a:t> cấp</a:t>
+                        <a:t> cung cấp cloud</a:t>
                       </a:r>
                       <a:r>
-                        <a:rPr lang="en-US" sz="2400" dirty="0" spc="0" kern="0">
-                          <a:solidFill>
-                            <a:srgbClr val="F3EEE3"/>
-                          </a:solidFill>
-                          <a:latin typeface="Be Vietnam Pro" pitchFamily="34" charset="0"/>
-                          <a:ea typeface="Be Vietnam Pro" pitchFamily="34" charset="-122"/>
-                          <a:cs typeface="Be Vietnam Pro" pitchFamily="34" charset="-120"/>
-                        </a:rPr>
-                        <a:t> cloud</a:t>
-                      </a:r>
-                      <a:r>
-                        <a:rPr lang="en-US" sz="2400" dirty="0" spc="-2" kern="0">
+                        <a:rPr lang="en-US" sz="2550" dirty="0" spc="-3" kern="0">
                           <a:solidFill>
                             <a:srgbClr val="F3EEE3"/>
                           </a:solidFill>
@@ -15278,7 +15245,7 @@
                         <a:t> hoặc</a:t>
                       </a:r>
                       <a:r>
-                        <a:rPr lang="en-US" sz="2400" dirty="0" spc="1" kern="0">
+                        <a:rPr lang="en-US" sz="2550" dirty="0" spc="1" kern="0">
                           <a:solidFill>
                             <a:srgbClr val="F3EEE3"/>
                           </a:solidFill>
@@ -15289,7 +15256,7 @@
                         <a:t> thành</a:t>
                       </a:r>
                       <a:r>
-                        <a:rPr lang="en-US" sz="2400" dirty="0" spc="2" kern="0">
+                        <a:rPr lang="en-US" sz="2550" dirty="0" spc="-1" kern="0">
                           <a:solidFill>
                             <a:srgbClr val="F3EEE3"/>
                           </a:solidFill>
@@ -15300,7 +15267,7 @@
                         <a:t> phần</a:t>
                       </a:r>
                       <a:r>
-                        <a:rPr lang="en-US" sz="2400" dirty="0" spc="-1" kern="0">
+                        <a:rPr lang="en-US" sz="2550" dirty="0" spc="-2" kern="0">
                           <a:solidFill>
                             <a:srgbClr val="F3EEE3"/>
                           </a:solidFill>
@@ -15311,7 +15278,7 @@
                         <a:t> như</a:t>
                       </a:r>
                       <a:r>
-                        <a:rPr lang="en-US" sz="2400" dirty="0" spc="-8" kern="0">
+                        <a:rPr lang="en-US" sz="2550" dirty="0" spc="-8" kern="0">
                           <a:solidFill>
                             <a:srgbClr val="F3EEE3"/>
                           </a:solidFill>
@@ -15324,7 +15291,7 @@
                       <a:endParaRPr lang="en-US" sz="1200" dirty="0"/>
                     </a:p>
                   </a:txBody>
-                  <a:tcPr marL="304800" marR="304800" marT="304800" marB="304800" anchor="ctr">
+                  <a:tcPr marL="304800" marR="304800" marT="300990" marB="300990" anchor="ctr">
                     <a:lnL w="19050" cap="flat" cmpd="sng" algn="ctr">
                       <a:solidFill>
                         <a:srgbClr val="3A3F4D"/>

</xml_diff>